<commit_message>
Move to kohli6/mcp-pulse: update links and rebuild deck
</commit_message>
<xml_diff>
--- a/docs/presentation/MCP_Pulse_Auto_Insurance.pptx
+++ b/docs/presentation/MCP_Pulse_Auto_Insurance.pptx
@@ -7900,7 +7900,7 @@
             </a:pPr>
             <a:r>
               <a:rPr sz="1400"/>
-              <a:t>github.com/hakohli/mcp-pulse  ·  branch: usecase/auto-insurance</a:t>
+              <a:t>github.com/kohli6/mcp-pulse  ·  branch: usecase/auto-insurance</a:t>
             </a:r>
           </a:p>
         </p:txBody>
@@ -8414,7 +8414,7 @@
             </a:pPr>
             <a:r>
               <a:rPr sz="1400"/>
-              <a:t>github.com/hakohli/mcp-pulse  ·  branch: usecase/auto-insurance</a:t>
+              <a:t>github.com/kohli6/mcp-pulse  ·  branch: usecase/auto-insurance</a:t>
             </a:r>
           </a:p>
           <a:p>

</xml_diff>